<commit_message>
docs: complete course navigation and verification evidence (#38)
</commit_message>
<xml_diff>
--- a/materials/slides/session-2.pptx
+++ b/materials/slides/session-2.pptx
@@ -18202,7 +18202,7 @@
         <p:spPr>
           <a:xfrm>
             <a:off x="594360" y="4611623"/>
-            <a:ext cx="11003279" cy="428244"/>
+            <a:ext cx="11003279" cy="780288"/>
           </a:xfrm>
           <a:prstGeom prst="rect">
             <a:avLst/>
@@ -18240,7 +18240,17 @@
                 </a:solidFill>
                 <a:latin typeface="Arial"/>
               </a:rPr>
-              <a:t>UI flow is conceptual here; frontend code is supplied later.</a:t>
+              <a:t>UI flow is conceptual here; the supplied frontend is explored in </a:t>
+            </a:r>
+            <a:br/>
+            <a:r>
+              <a:rPr sz="2100" b="0" i="0">
+                <a:solidFill>
+                  <a:srgbClr val="20344A"/>
+                </a:solidFill>
+                <a:latin typeface="Arial"/>
+              </a:rPr>
+              <a:t>Session 4.</a:t>
             </a:r>
           </a:p>
         </p:txBody>

</xml_diff>